<commit_message>
sd-02-031: no invented gateway-team queue; generation-two trouble marked as general reasoning
Co-Authored-By: Claude Opus 5.5 <noreply@anthropic.com>
Claude-Session: https://claude.ai/code/session_01McBLtMnJbTnB94NeVs8a2V
</commit_message>
<xml_diff>
--- a/system-design-101/vi/lessons/sd-02-031/slides/sd-02-031.pptx
+++ b/system-design-101/vi/lessons/sd-02-031/slides/sd-02-031.pptx
@@ -8498,7 +8498,7 @@
               <a:buNone/>
             </a:pPr>
             <a:r>
-              <a:rPr lang="en-US" sz="3300" dirty="0" spc="1" kern="0">
+              <a:rPr lang="en-US" sz="3300" dirty="0" spc="-2" kern="0">
                 <a:solidFill>
                   <a:srgbClr val="E4E1D8"/>
                 </a:solidFill>
@@ -8506,10 +8506,10 @@
                 <a:ea typeface="Bricolage Grotesque ExtraBold" pitchFamily="34" charset="-122"/>
                 <a:cs typeface="Bricolage Grotesque ExtraBold" pitchFamily="34" charset="-120"/>
               </a:rPr>
-              <a:t>Phải</a:t>
-            </a:r>
-            <a:r>
-              <a:rPr lang="en-US" sz="3300" dirty="0" spc="2" kern="0">
+              <a:t>Mọi API</a:t>
+            </a:r>
+            <a:r>
+              <a:rPr lang="en-US" sz="3300" dirty="0" spc="-1" kern="0">
                 <a:solidFill>
                   <a:srgbClr val="E4E1D8"/>
                 </a:solidFill>
@@ -8517,10 +8517,10 @@
                 <a:ea typeface="Bricolage Grotesque ExtraBold" pitchFamily="34" charset="-122"/>
                 <a:cs typeface="Bricolage Grotesque ExtraBold" pitchFamily="34" charset="-120"/>
               </a:rPr>
-              <a:t> chờ</a:t>
-            </a:r>
-            <a:r>
-              <a:rPr lang="en-US" sz="3300" dirty="0" spc="3" kern="0">
+              <a:t> dồn</a:t>
+            </a:r>
+            <a:r>
+              <a:rPr lang="en-US" sz="3300" dirty="0" spc="-28" kern="0">
                 <a:solidFill>
                   <a:srgbClr val="E4E1D8"/>
                 </a:solidFill>
@@ -8528,10 +8528,10 @@
                 <a:ea typeface="Bricolage Grotesque ExtraBold" pitchFamily="34" charset="-122"/>
                 <a:cs typeface="Bricolage Grotesque ExtraBold" pitchFamily="34" charset="-120"/>
               </a:rPr>
-              <a:t> đội</a:t>
-            </a:r>
-            <a:r>
-              <a:rPr lang="en-US" sz="3300" dirty="0" spc="-4" kern="0">
+              <a:t> vào</a:t>
+            </a:r>
+            <a:r>
+              <a:rPr lang="en-US" sz="3300" dirty="0" spc="-6" kern="0">
                 <a:solidFill>
                   <a:srgbClr val="E4E1D8"/>
                 </a:solidFill>
@@ -8539,7 +8539,7 @@
                 <a:ea typeface="Bricolage Grotesque ExtraBold" pitchFamily="34" charset="-122"/>
                 <a:cs typeface="Bricolage Grotesque ExtraBold" pitchFamily="34" charset="-120"/>
               </a:rPr>
-              <a:t> giữ</a:t>
+              <a:t> một</a:t>
             </a:r>
             <a:r>
               <a:rPr lang="en-US" sz="3300" dirty="0" spc="0" kern="0">
@@ -8692,7 +8692,7 @@
               <a:buNone/>
             </a:pPr>
             <a:r>
-              <a:rPr lang="en-US" sz="3300" dirty="0" spc="2" kern="0">
+              <a:rPr lang="en-US" sz="3300" dirty="0" spc="-28" kern="0">
                 <a:solidFill>
                   <a:srgbClr val="14161C"/>
                 </a:solidFill>
@@ -8700,7 +8700,7 @@
                 <a:ea typeface="Bricolage Grotesque ExtraBold" pitchFamily="34" charset="-122"/>
                 <a:cs typeface="Bricolage Grotesque ExtraBold" pitchFamily="34" charset="-120"/>
               </a:rPr>
-              <a:t>Không</a:t>
+              <a:t>Tự</a:t>
             </a:r>
             <a:r>
               <a:rPr lang="en-US" sz="3300" dirty="0" spc="1" kern="0">
@@ -8711,10 +8711,10 @@
                 <a:ea typeface="Bricolage Grotesque ExtraBold" pitchFamily="34" charset="-122"/>
                 <a:cs typeface="Bricolage Grotesque ExtraBold" pitchFamily="34" charset="-120"/>
               </a:rPr>
-              <a:t> chờ</a:t>
-            </a:r>
-            <a:r>
-              <a:rPr lang="en-US" sz="3300" dirty="0" spc="4" kern="0">
+              <a:t> phục</a:t>
+            </a:r>
+            <a:r>
+              <a:rPr lang="en-US" sz="3300" dirty="0" spc="-3" kern="0">
                 <a:solidFill>
                   <a:srgbClr val="14161C"/>
                 </a:solidFill>
@@ -8722,10 +8722,10 @@
                 <a:ea typeface="Bricolage Grotesque ExtraBold" pitchFamily="34" charset="-122"/>
                 <a:cs typeface="Bricolage Grotesque ExtraBold" pitchFamily="34" charset="-120"/>
               </a:rPr>
-              <a:t> đội</a:t>
-            </a:r>
-            <a:r>
-              <a:rPr lang="en-US" sz="3300" dirty="0" spc="-4" kern="0">
+              <a:t> vụ,</a:t>
+            </a:r>
+            <a:r>
+              <a:rPr lang="en-US" sz="3300" dirty="0" spc="1" kern="0">
                 <a:solidFill>
                   <a:srgbClr val="14161C"/>
                 </a:solidFill>
@@ -8733,10 +8733,10 @@
                 <a:ea typeface="Bricolage Grotesque ExtraBold" pitchFamily="34" charset="-122"/>
                 <a:cs typeface="Bricolage Grotesque ExtraBold" pitchFamily="34" charset="-120"/>
               </a:rPr>
-              <a:t> giữ</a:t>
-            </a:r>
-            <a:r>
-              <a:rPr lang="en-US" sz="3300" dirty="0" spc="0" kern="0">
+              <a:t> chia</a:t>
+            </a:r>
+            <a:r>
+              <a:rPr lang="en-US" sz="3300" dirty="0" spc="-1" kern="0">
                 <a:solidFill>
                   <a:srgbClr val="14161C"/>
                 </a:solidFill>
@@ -8744,18 +8744,7 @@
                 <a:ea typeface="Bricolage Grotesque ExtraBold" pitchFamily="34" charset="-122"/>
                 <a:cs typeface="Bricolage Grotesque ExtraBold" pitchFamily="34" charset="-120"/>
               </a:rPr>
-              <a:t> cổng</a:t>
-            </a:r>
-            <a:r>
-              <a:rPr lang="en-US" sz="3300" dirty="0" spc="1" kern="0">
-                <a:solidFill>
-                  <a:srgbClr val="14161C"/>
-                </a:solidFill>
-                <a:latin typeface="Bricolage Grotesque ExtraBold" pitchFamily="34" charset="0"/>
-                <a:ea typeface="Bricolage Grotesque ExtraBold" pitchFamily="34" charset="-122"/>
-                <a:cs typeface="Bricolage Grotesque ExtraBold" pitchFamily="34" charset="-120"/>
-              </a:rPr>
-              <a:t> chung</a:t>
+              <a:t> tầng</a:t>
             </a:r>
             <a:endParaRPr lang="en-US" sz="3300" dirty="0"/>
           </a:p>
@@ -9354,7 +9343,7 @@
               <a:buNone/>
             </a:pPr>
             <a:r>
-              <a:rPr lang="en-US" sz="1950" b="1" spc="226" kern="0" dirty="0">
+              <a:rPr lang="en-US" sz="1950" b="1" spc="227" kern="0" dirty="0">
                 <a:solidFill>
                   <a:srgbClr val="B45309"/>
                 </a:solidFill>
@@ -9362,10 +9351,10 @@
                 <a:ea typeface="Be Vietnam Pro" pitchFamily="34" charset="-122"/>
                 <a:cs typeface="Be Vietnam Pro" pitchFamily="34" charset="-120"/>
               </a:rPr>
-              <a:t>NÚT</a:t>
-            </a:r>
-            <a:r>
-              <a:rPr lang="en-US" sz="1950" b="1" spc="185" kern="0" dirty="0">
+              <a:t>PHÌNH</a:t>
+            </a:r>
+            <a:r>
+              <a:rPr lang="en-US" sz="1950" b="1" spc="195" kern="0" dirty="0">
                 <a:solidFill>
                   <a:srgbClr val="B45309"/>
                 </a:solidFill>
@@ -9373,7 +9362,7 @@
                 <a:ea typeface="Be Vietnam Pro" pitchFamily="34" charset="-122"/>
                 <a:cs typeface="Be Vietnam Pro" pitchFamily="34" charset="-120"/>
               </a:rPr>
-              <a:t> THẮT</a:t>
+              <a:t> TO</a:t>
             </a:r>
             <a:endParaRPr lang="en-US" sz="1950" dirty="0"/>
           </a:p>
@@ -9404,7 +9393,7 @@
               <a:buNone/>
             </a:pPr>
             <a:r>
-              <a:rPr lang="en-US" sz="2850" b="1" dirty="0" spc="-2" kern="0">
+              <a:rPr lang="en-US" sz="2850" b="1" dirty="0" spc="0" kern="0">
                 <a:solidFill>
                   <a:srgbClr val="14161C"/>
                 </a:solidFill>
@@ -9412,7 +9401,51 @@
                 <a:ea typeface="Be Vietnam Pro" pitchFamily="34" charset="-122"/>
                 <a:cs typeface="Be Vietnam Pro" pitchFamily="34" charset="-120"/>
               </a:rPr>
-              <a:t>Mọi</a:t>
+              <a:t>Nhiều</a:t>
+            </a:r>
+            <a:r>
+              <a:rPr lang="en-US" sz="2850" b="1" dirty="0" spc="8" kern="0">
+                <a:solidFill>
+                  <a:srgbClr val="14161C"/>
+                </a:solidFill>
+                <a:latin typeface="Be Vietnam Pro" pitchFamily="34" charset="0"/>
+                <a:ea typeface="Be Vietnam Pro" pitchFamily="34" charset="-122"/>
+                <a:cs typeface="Be Vietnam Pro" pitchFamily="34" charset="-120"/>
+              </a:rPr>
+              <a:t> đội</a:t>
+            </a:r>
+            <a:r>
+              <a:rPr lang="en-US" sz="2850" b="1" dirty="0" spc="0" kern="0">
+                <a:solidFill>
+                  <a:srgbClr val="14161C"/>
+                </a:solidFill>
+                <a:latin typeface="Be Vietnam Pro" pitchFamily="34" charset="0"/>
+                <a:ea typeface="Be Vietnam Pro" pitchFamily="34" charset="-122"/>
+                <a:cs typeface="Be Vietnam Pro" pitchFamily="34" charset="-120"/>
+              </a:rPr>
+              <a:t> cùng</a:t>
+            </a:r>
+            <a:r>
+              <a:rPr lang="en-US" sz="2850" b="1" dirty="0" spc="-6" kern="0">
+                <a:solidFill>
+                  <a:srgbClr val="14161C"/>
+                </a:solidFill>
+                <a:latin typeface="Be Vietnam Pro" pitchFamily="34" charset="0"/>
+                <a:ea typeface="Be Vietnam Pro" pitchFamily="34" charset="-122"/>
+                <a:cs typeface="Be Vietnam Pro" pitchFamily="34" charset="-120"/>
+              </a:rPr>
+              <a:t> thêm</a:t>
+            </a:r>
+            <a:r>
+              <a:rPr lang="en-US" sz="2850" b="1" dirty="0" spc="-11" kern="0">
+                <a:solidFill>
+                  <a:srgbClr val="14161C"/>
+                </a:solidFill>
+                <a:latin typeface="Be Vietnam Pro" pitchFamily="34" charset="0"/>
+                <a:ea typeface="Be Vietnam Pro" pitchFamily="34" charset="-122"/>
+                <a:cs typeface="Be Vietnam Pro" pitchFamily="34" charset="-120"/>
+              </a:rPr>
+              <a:t> vào</a:t>
             </a:r>
             <a:r>
               <a:rPr lang="en-US" sz="2850" b="1" dirty="0" spc="-10" kern="0">
@@ -9423,10 +9456,10 @@
                 <a:ea typeface="Be Vietnam Pro" pitchFamily="34" charset="-122"/>
                 <a:cs typeface="Be Vietnam Pro" pitchFamily="34" charset="-120"/>
               </a:rPr>
-              <a:t> thay</a:t>
-            </a:r>
-            <a:r>
-              <a:rPr lang="en-US" sz="2850" b="1" dirty="0" spc="9" kern="0">
+              <a:t> một</a:t>
+            </a:r>
+            <a:r>
+              <a:rPr lang="en-US" sz="2850" b="1" dirty="0" spc="-6" kern="0">
                 <a:solidFill>
                   <a:srgbClr val="14161C"/>
                 </a:solidFill>
@@ -9434,40 +9467,7 @@
                 <a:ea typeface="Be Vietnam Pro" pitchFamily="34" charset="-122"/>
                 <a:cs typeface="Be Vietnam Pro" pitchFamily="34" charset="-120"/>
               </a:rPr>
-              <a:t> đổi</a:t>
-            </a:r>
-            <a:r>
-              <a:rPr lang="en-US" sz="2850" b="1" dirty="0" spc="-3" kern="0">
-                <a:solidFill>
-                  <a:srgbClr val="14161C"/>
-                </a:solidFill>
-                <a:latin typeface="Be Vietnam Pro" pitchFamily="34" charset="0"/>
-                <a:ea typeface="Be Vietnam Pro" pitchFamily="34" charset="-122"/>
-                <a:cs typeface="Be Vietnam Pro" pitchFamily="34" charset="-120"/>
-              </a:rPr>
-              <a:t> chờ</a:t>
-            </a:r>
-            <a:r>
-              <a:rPr lang="en-US" sz="2850" b="1" dirty="0" spc="-9" kern="0">
-                <a:solidFill>
-                  <a:srgbClr val="14161C"/>
-                </a:solidFill>
-                <a:latin typeface="Be Vietnam Pro" pitchFamily="34" charset="0"/>
-                <a:ea typeface="Be Vietnam Pro" pitchFamily="34" charset="-122"/>
-                <a:cs typeface="Be Vietnam Pro" pitchFamily="34" charset="-120"/>
-              </a:rPr>
-              <a:t> một</a:t>
-            </a:r>
-            <a:r>
-              <a:rPr lang="en-US" sz="2850" b="1" dirty="0" spc="8" kern="0">
-                <a:solidFill>
-                  <a:srgbClr val="14161C"/>
-                </a:solidFill>
-                <a:latin typeface="Be Vietnam Pro" pitchFamily="34" charset="0"/>
-                <a:ea typeface="Be Vietnam Pro" pitchFamily="34" charset="-122"/>
-                <a:cs typeface="Be Vietnam Pro" pitchFamily="34" charset="-120"/>
-              </a:rPr>
-              <a:t> đội</a:t>
+              <a:t> cổng</a:t>
             </a:r>
             <a:endParaRPr lang="en-US" sz="2850" dirty="0"/>
           </a:p>

</xml_diff>